<commit_message>
Fix PPTX 404, drop slide text, rewrite benchmarking protocols
- Stage .pptx files into the site so the deck link resolves.
- Remove RESAC_2026_slides.md and its duplicate .pptx; the deck's speaker
  notes now carry the full script plus the session, thesis, speaker and
  sources front matter.
- Rewrite docs/benchmarking_protocols.md to describe the suite as run:
  OpenRouter via httpx, temperature 0 and 65,536 max tokens, reasoning
  effort with escalation, the 13 tasks, the shared system prompt, the
  judge panel with median-of-three tie-break, CER, clean-suite gates, and
  output columns.
- Replace LaTeX math ($\rightarrow$, $\ge$, Greek in $\mathrm{}$) with
  Unicode in five documents.
- Scoring page: the tie-break takes the median of three judges.

Co-Authored-By: Claude Opus 5.5 <noreply@anthropic.com>
</commit_message>
<xml_diff>
--- a/resac2026/RESAC_2026_From_Author_to_Editor.pptx
+++ b/resac2026/RESAC_2026_From_Author_to_Editor.pptx
@@ -549,6 +549,35 @@
           <a:p>
             <a:r>
               <a:t>KEN: So the question is no longer whether AI saves time in editing ancient texts. The question is where the saved time goes, and what that does to the people who do the work. That's what we want to talk about today.</a:t>
+            </a:r>
+          </a:p>
+          <a:p/>
+          <a:p>
+            <a:r>
+              <a:t>--- CONTEXT ---</a:t>
+            </a:r>
+          </a:p>
+          <a:p>
+            <a:r>
+              <a:t>Conference: RESAC 2026 (Teaching, Technology, and the Future of Religious Studies). Session: Saturday, September 26, 2026, 1:30–3:00 PM, Panel 4, Memorial University. Format: 11 slides, about 15:45 delivery, plus Q&amp;A. Co-presenters: Dr. Ken M. Penner (Principal Investigator, St. Francis Xavier University) and Demarquis Moss (Lead Research Assistant). Project: SSHRC Insight Development Grant R0253025.</a:t>
+            </a:r>
+          </a:p>
+          <a:p/>
+          <a:p>
+            <a:r>
+              <a:t>Thesis: AI does not remove the scholar. It moves every member of the team up one rung: the drafting moves to the machine, and human effort shifts to the start and end of a project, where the most discernment is needed.</a:t>
+            </a:r>
+          </a:p>
+          <a:p/>
+          <a:p>
+            <a:r>
+              <a:t>Who speaks: Demarquis speaks in the first person where the evidence is his own work (his timings on Slide 1, the benchmark, the 90/10/1 flow, the limits, his example on Slide 8, the recommendations; about 7 minutes). Ken opens, carries the argument and closes (about 8½ minutes). Each slide's notes name its speaker; in the scripts, a name marks each change of speaker.</a:t>
+            </a:r>
+          </a:p>
+          <a:p/>
+          <a:p>
+            <a:r>
+              <a:t>Sources: Every figure comes from resac2026/clean_suite_master.csv and clean_suite_visual_cer.csv (57 configurations of 44 models that pass the coverage and cache-replay gates, rebuilt 2026-09-22) or from resac2026/PROVENANCE.md. The timing figures on Slides 1 and 3 are the project's own experience and are presented as such.</a:t>
             </a:r>
           </a:p>
           <a:p/>

</xml_diff>